<commit_message>
Actualizar presentación IBER: logo oficial y slide 4 con evolución por eje
- Portada: fondo claro (igual que el resto de las slides del equipo) y
  logo oficial completo de 00__Identidad_Consultora/logo_next_step.svg,
  que estaba pensado para fondo claro y no se leía sobre fondo oscuro.
- Slide de cierre: reemplaza la línea de tiempo de sprints por los 4 ejes
  de arquitectura empresarial (Negocio, Datos, Aplicaciones, Tecnología)
  que estructuran los templates 02 y 03, mostrando actual → destino.

Co-Authored-By: Claude Sonnet 5 <noreply@anthropic.com>
Claude-Session: https://claude.ai/code/session_01PhicoTLWNpVDnxtM4x4MRN
</commit_message>
<xml_diff>
--- a/000_Presentaciones/Presentacion_IBER_Sprint1.pptx
+++ b/000_Presentaciones/Presentacion_IBER_Sprint1.pptx
@@ -1157,7 +1157,7 @@
     <p:bg>
       <p:bgPr>
         <a:solidFill>
-          <a:srgbClr val="241017"/>
+          <a:srgbClr val="FBF6EE"/>
         </a:solidFill>
       </p:bgPr>
     </p:bg>
@@ -1177,7 +1177,7 @@
       </p:grpSpPr>
       <p:pic>
         <p:nvPicPr>
-          <p:cNvPr id="2" name="Image 0" descr="./logo.png">    </p:cNvPr>
+          <p:cNvPr id="2" name="Image 0" descr="./logo_pptx.png">    </p:cNvPr>
           <p:cNvPicPr>
             <a:picLocks noChangeAspect="1"/>
           </p:cNvPicPr>
@@ -1191,8 +1191,8 @@
         </p:blipFill>
         <p:spPr>
           <a:xfrm>
-            <a:off x="548640" y="502920"/>
-            <a:ext cx="960120" cy="825275"/>
+            <a:off x="548640" y="457200"/>
+            <a:ext cx="1554480" cy="1336853"/>
           </a:xfrm>
           <a:prstGeom prst="rect">
             <a:avLst/>
@@ -1202,84 +1202,6 @@
       <p:sp>
         <p:nvSpPr>
           <p:cNvPr id="3" name="Text 0"/>
-          <p:cNvSpPr txBox="1"/>
-          <p:nvPr/>
-        </p:nvSpPr>
-        <p:spPr>
-          <a:xfrm>
-            <a:off x="1691640" y="685800"/>
-            <a:ext cx="3657600" cy="548640"/>
-          </a:xfrm>
-          <a:prstGeom prst="rect">
-            <a:avLst/>
-          </a:prstGeom>
-          <a:noFill/>
-          <a:ln/>
-        </p:spPr>
-        <p:txBody>
-          <a:bodyPr wrap="square" lIns="0" tIns="0" rIns="0" bIns="0" rtlCol="0" anchor="ctr"/>
-          <a:lstStyle/>
-          <a:p>
-            <a:pPr indent="0" marL="0">
-              <a:buNone/>
-            </a:pPr>
-            <a:r>
-              <a:rPr lang="en-US" sz="1600" b="1" spc="400" kern="0" dirty="0">
-                <a:solidFill>
-                  <a:srgbClr val="EEE0CB"/>
-                </a:solidFill>
-                <a:latin typeface="Poppins" pitchFamily="34" charset="0"/>
-                <a:ea typeface="Poppins" pitchFamily="34" charset="-122"/>
-                <a:cs typeface="Poppins" pitchFamily="34" charset="-120"/>
-              </a:rPr>
-              <a:t>NEXTSTEP</a:t>
-            </a:r>
-            <a:endParaRPr lang="en-US" sz="1600" dirty="0"/>
-          </a:p>
-        </p:txBody>
-      </p:sp>
-      <p:sp>
-        <p:nvSpPr>
-          <p:cNvPr id="4" name="Text 1"/>
-          <p:cNvSpPr txBox="1"/>
-          <p:nvPr/>
-        </p:nvSpPr>
-        <p:spPr>
-          <a:xfrm>
-            <a:off x="1691640" y="1051560"/>
-            <a:ext cx="3657600" cy="365760"/>
-          </a:xfrm>
-          <a:prstGeom prst="rect">
-            <a:avLst/>
-          </a:prstGeom>
-          <a:noFill/>
-          <a:ln/>
-        </p:spPr>
-        <p:txBody>
-          <a:bodyPr wrap="square" lIns="0" tIns="0" rIns="0" bIns="0" rtlCol="0" anchor="ctr"/>
-          <a:lstStyle/>
-          <a:p>
-            <a:pPr indent="0" marL="0">
-              <a:buNone/>
-            </a:pPr>
-            <a:r>
-              <a:rPr lang="en-US" sz="1100" i="1" dirty="0">
-                <a:solidFill>
-                  <a:srgbClr val="BAA898"/>
-                </a:solidFill>
-                <a:latin typeface="Poppins" pitchFamily="34" charset="0"/>
-                <a:ea typeface="Poppins" pitchFamily="34" charset="-122"/>
-                <a:cs typeface="Poppins" pitchFamily="34" charset="-120"/>
-              </a:rPr>
-              <a:t>Consultoría en Tecnología</a:t>
-            </a:r>
-            <a:endParaRPr lang="en-US" sz="1100" dirty="0"/>
-          </a:p>
-        </p:txBody>
-      </p:sp>
-      <p:sp>
-        <p:nvSpPr>
-          <p:cNvPr id="5" name="Text 2"/>
           <p:cNvSpPr txBox="1"/>
           <p:nvPr/>
         </p:nvSpPr>
@@ -1304,7 +1226,7 @@
             <a:r>
               <a:rPr lang="en-US" sz="5000" b="1" dirty="0">
                 <a:solidFill>
-                  <a:srgbClr val="EEE0CB"/>
+                  <a:srgbClr val="4A1B27"/>
                 </a:solidFill>
                 <a:latin typeface="IBM Plex Serif" pitchFamily="34" charset="0"/>
                 <a:ea typeface="IBM Plex Serif" pitchFamily="34" charset="-122"/>
@@ -1318,7 +1240,7 @@
       </p:sp>
       <p:sp>
         <p:nvSpPr>
-          <p:cNvPr id="6" name="Text 3"/>
+          <p:cNvPr id="4" name="Text 1"/>
           <p:cNvSpPr txBox="1"/>
           <p:nvPr/>
         </p:nvSpPr>
@@ -1343,7 +1265,7 @@
             <a:r>
               <a:rPr lang="en-US" sz="2000" dirty="0">
                 <a:solidFill>
-                  <a:srgbClr val="C2847A"/>
+                  <a:srgbClr val="6B2737"/>
                 </a:solidFill>
                 <a:latin typeface="Poppins" pitchFamily="34" charset="0"/>
                 <a:ea typeface="Poppins" pitchFamily="34" charset="-122"/>
@@ -1357,7 +1279,7 @@
       </p:sp>
       <p:sp>
         <p:nvSpPr>
-          <p:cNvPr id="7" name="Text 4"/>
+          <p:cNvPr id="5" name="Text 2"/>
           <p:cNvSpPr txBox="1"/>
           <p:nvPr/>
         </p:nvSpPr>
@@ -1396,7 +1318,7 @@
       </p:sp>
       <p:sp>
         <p:nvSpPr>
-          <p:cNvPr id="8" name="Shape 5"/>
+          <p:cNvPr id="6" name="Shape 3"/>
           <p:cNvSpPr/>
           <p:nvPr/>
         </p:nvSpPr>
@@ -1418,7 +1340,7 @@
       </p:sp>
       <p:sp>
         <p:nvSpPr>
-          <p:cNvPr id="9" name="Text 6"/>
+          <p:cNvPr id="7" name="Text 4"/>
           <p:cNvSpPr txBox="1"/>
           <p:nvPr/>
         </p:nvSpPr>
@@ -1457,7 +1379,7 @@
       </p:sp>
       <p:sp>
         <p:nvSpPr>
-          <p:cNvPr id="10" name="Text 7"/>
+          <p:cNvPr id="8" name="Text 5"/>
           <p:cNvSpPr txBox="1"/>
           <p:nvPr/>
         </p:nvSpPr>
@@ -1496,7 +1418,7 @@
       </p:sp>
       <p:sp>
         <p:nvSpPr>
-          <p:cNvPr id="11" name="Text 8"/>
+          <p:cNvPr id="9" name="Text 6"/>
           <p:cNvSpPr txBox="1"/>
           <p:nvPr/>
         </p:nvSpPr>
@@ -1535,7 +1457,7 @@
       </p:sp>
       <p:sp>
         <p:nvSpPr>
-          <p:cNvPr id="12" name="Text 9"/>
+          <p:cNvPr id="10" name="Text 7"/>
           <p:cNvSpPr txBox="1"/>
           <p:nvPr/>
         </p:nvSpPr>
@@ -4035,7 +3957,7 @@
     <p:bg>
       <p:bgPr>
         <a:solidFill>
-          <a:srgbClr val="241017"/>
+          <a:srgbClr val="6B2737"/>
         </a:solidFill>
       </p:bgPr>
     </p:bg>
@@ -4061,8 +3983,8 @@
         </p:nvSpPr>
         <p:spPr>
           <a:xfrm>
-            <a:off x="548640" y="548640"/>
-            <a:ext cx="11064240" cy="731520"/>
+            <a:off x="548640" y="502920"/>
+            <a:ext cx="11064240" cy="640080"/>
           </a:xfrm>
           <a:prstGeom prst="rect">
             <a:avLst/>
@@ -4078,7 +4000,7 @@
               <a:buNone/>
             </a:pPr>
             <a:r>
-              <a:rPr lang="en-US" sz="3400" b="1" dirty="0">
+              <a:rPr lang="en-US" sz="3200" b="1" dirty="0">
                 <a:solidFill>
                   <a:srgbClr val="EEE0CB"/>
                 </a:solidFill>
@@ -4088,7 +4010,7 @@
               </a:rPr>
               <a:t>Próximos pasos</a:t>
             </a:r>
-            <a:endParaRPr lang="en-US" sz="3400" dirty="0"/>
+            <a:endParaRPr lang="en-US" sz="3200" dirty="0"/>
           </a:p>
         </p:txBody>
       </p:sp>
@@ -4100,7 +4022,7 @@
         </p:nvSpPr>
         <p:spPr>
           <a:xfrm>
-            <a:off x="548640" y="1234440"/>
+            <a:off x="548640" y="1115568"/>
             <a:ext cx="10972800" cy="365760"/>
           </a:xfrm>
           <a:prstGeom prst="rect">
@@ -4117,7 +4039,7 @@
               <a:buNone/>
             </a:pPr>
             <a:r>
-              <a:rPr lang="en-US" sz="1500" dirty="0">
+              <a:rPr lang="en-US" sz="1400" dirty="0">
                 <a:solidFill>
                   <a:srgbClr val="C2847A"/>
                 </a:solidFill>
@@ -4127,7 +4049,7 @@
               </a:rPr>
               <a:t>Épica 2 — Diseñar la transformación</a:t>
             </a:r>
-            <a:endParaRPr lang="en-US" sz="1500" dirty="0"/>
+            <a:endParaRPr lang="en-US" sz="1400" dirty="0"/>
           </a:p>
         </p:txBody>
       </p:sp>
@@ -4139,14 +4061,209 @@
         </p:nvSpPr>
         <p:spPr>
           <a:xfrm>
-            <a:off x="1143000" y="3291840"/>
-            <a:ext cx="9921240" cy="0"/>
-          </a:xfrm>
-          <a:prstGeom prst="line">
-            <a:avLst/>
-          </a:prstGeom>
-          <a:noFill/>
-          <a:ln w="19050">
+            <a:off x="548640" y="1691640"/>
+            <a:ext cx="3200400" cy="384048"/>
+          </a:xfrm>
+          <a:prstGeom prst="roundRect">
+            <a:avLst>
+              <a:gd name="adj" fmla="val 50000"/>
+            </a:avLst>
+          </a:prstGeom>
+          <a:solidFill>
+            <a:srgbClr val="C2847A"/>
+          </a:solidFill>
+          <a:ln/>
+        </p:spPr>
+      </p:sp>
+      <p:sp>
+        <p:nvSpPr>
+          <p:cNvPr id="5" name="Text 3"/>
+          <p:cNvSpPr txBox="1"/>
+          <p:nvPr/>
+        </p:nvSpPr>
+        <p:spPr>
+          <a:xfrm>
+            <a:off x="548640" y="1691640"/>
+            <a:ext cx="3200400" cy="384048"/>
+          </a:xfrm>
+          <a:prstGeom prst="rect">
+            <a:avLst/>
+          </a:prstGeom>
+          <a:noFill/>
+          <a:ln/>
+        </p:spPr>
+        <p:txBody>
+          <a:bodyPr wrap="square" lIns="0" tIns="0" rIns="0" bIns="0" rtlCol="0" anchor="ctr"/>
+          <a:lstStyle/>
+          <a:p>
+            <a:pPr algn="ctr" indent="0" marL="0">
+              <a:buNone/>
+            </a:pPr>
+            <a:r>
+              <a:rPr lang="en-US" sz="1200" b="1" dirty="0">
+                <a:solidFill>
+                  <a:srgbClr val="FFFFFF"/>
+                </a:solidFill>
+                <a:latin typeface="Poppins" pitchFamily="34" charset="0"/>
+                <a:ea typeface="Poppins" pitchFamily="34" charset="-122"/>
+                <a:cs typeface="Poppins" pitchFamily="34" charset="-120"/>
+              </a:rPr>
+              <a:t>T-02 · Actual  </a:t>
+            </a:r>
+            <a:pPr algn="ctr" indent="0" marL="0">
+              <a:buNone/>
+            </a:pPr>
+            <a:r>
+              <a:rPr lang="en-US" sz="1200" dirty="0">
+                <a:solidFill>
+                  <a:srgbClr val="FFFFFF"/>
+                </a:solidFill>
+                <a:latin typeface="Poppins" pitchFamily="34" charset="0"/>
+                <a:ea typeface="Poppins" pitchFamily="34" charset="-122"/>
+                <a:cs typeface="Poppins" pitchFamily="34" charset="-120"/>
+              </a:rPr>
+              <a:t>· 03/09 · hoy</a:t>
+            </a:r>
+            <a:endParaRPr lang="en-US" sz="1200" dirty="0"/>
+          </a:p>
+        </p:txBody>
+      </p:sp>
+      <p:sp>
+        <p:nvSpPr>
+          <p:cNvPr id="6" name="Text 4"/>
+          <p:cNvSpPr txBox="1"/>
+          <p:nvPr/>
+        </p:nvSpPr>
+        <p:spPr>
+          <a:xfrm>
+            <a:off x="3840480" y="1691640"/>
+            <a:ext cx="457200" cy="384048"/>
+          </a:xfrm>
+          <a:prstGeom prst="rect">
+            <a:avLst/>
+          </a:prstGeom>
+          <a:noFill/>
+          <a:ln/>
+        </p:spPr>
+        <p:txBody>
+          <a:bodyPr wrap="square" lIns="0" tIns="0" rIns="0" bIns="0" rtlCol="0" anchor="ctr"/>
+          <a:lstStyle/>
+          <a:p>
+            <a:pPr algn="ctr" indent="0" marL="0">
+              <a:buNone/>
+            </a:pPr>
+            <a:r>
+              <a:rPr lang="en-US" sz="1600" b="1" dirty="0">
+                <a:solidFill>
+                  <a:srgbClr val="EEE0CB"/>
+                </a:solidFill>
+                <a:latin typeface="Poppins" pitchFamily="34" charset="0"/>
+                <a:ea typeface="Poppins" pitchFamily="34" charset="-122"/>
+                <a:cs typeface="Poppins" pitchFamily="34" charset="-120"/>
+              </a:rPr>
+              <a:t>→</a:t>
+            </a:r>
+            <a:endParaRPr lang="en-US" sz="1600" dirty="0"/>
+          </a:p>
+        </p:txBody>
+      </p:sp>
+      <p:sp>
+        <p:nvSpPr>
+          <p:cNvPr id="7" name="Shape 5"/>
+          <p:cNvSpPr/>
+          <p:nvPr/>
+        </p:nvSpPr>
+        <p:spPr>
+          <a:xfrm>
+            <a:off x="4389120" y="1691640"/>
+            <a:ext cx="2926080" cy="384048"/>
+          </a:xfrm>
+          <a:prstGeom prst="roundRect">
+            <a:avLst>
+              <a:gd name="adj" fmla="val 50000"/>
+            </a:avLst>
+          </a:prstGeom>
+          <a:solidFill>
+            <a:srgbClr val="4A1B27"/>
+          </a:solidFill>
+          <a:ln/>
+        </p:spPr>
+      </p:sp>
+      <p:sp>
+        <p:nvSpPr>
+          <p:cNvPr id="8" name="Text 6"/>
+          <p:cNvSpPr txBox="1"/>
+          <p:nvPr/>
+        </p:nvSpPr>
+        <p:spPr>
+          <a:xfrm>
+            <a:off x="4389120" y="1691640"/>
+            <a:ext cx="2926080" cy="384048"/>
+          </a:xfrm>
+          <a:prstGeom prst="rect">
+            <a:avLst/>
+          </a:prstGeom>
+          <a:noFill/>
+          <a:ln/>
+        </p:spPr>
+        <p:txBody>
+          <a:bodyPr wrap="square" lIns="0" tIns="0" rIns="0" bIns="0" rtlCol="0" anchor="ctr"/>
+          <a:lstStyle/>
+          <a:p>
+            <a:pPr algn="ctr" indent="0" marL="0">
+              <a:buNone/>
+            </a:pPr>
+            <a:r>
+              <a:rPr lang="en-US" sz="1200" b="1" dirty="0">
+                <a:solidFill>
+                  <a:srgbClr val="EEE0CB"/>
+                </a:solidFill>
+                <a:latin typeface="Poppins" pitchFamily="34" charset="0"/>
+                <a:ea typeface="Poppins" pitchFamily="34" charset="-122"/>
+                <a:cs typeface="Poppins" pitchFamily="34" charset="-120"/>
+              </a:rPr>
+              <a:t>T-03 · Destino  </a:t>
+            </a:r>
+            <a:pPr algn="ctr" indent="0" marL="0">
+              <a:buNone/>
+            </a:pPr>
+            <a:r>
+              <a:rPr lang="en-US" sz="1200" dirty="0">
+                <a:solidFill>
+                  <a:srgbClr val="EEE0CB"/>
+                </a:solidFill>
+                <a:latin typeface="Poppins" pitchFamily="34" charset="0"/>
+                <a:ea typeface="Poppins" pitchFamily="34" charset="-122"/>
+                <a:cs typeface="Poppins" pitchFamily="34" charset="-120"/>
+              </a:rPr>
+              <a:t>· 10/09</a:t>
+            </a:r>
+            <a:endParaRPr lang="en-US" sz="1200" dirty="0"/>
+          </a:p>
+        </p:txBody>
+      </p:sp>
+      <p:sp>
+        <p:nvSpPr>
+          <p:cNvPr id="9" name="Shape 7"/>
+          <p:cNvSpPr/>
+          <p:nvPr/>
+        </p:nvSpPr>
+        <p:spPr>
+          <a:xfrm>
+            <a:off x="548640" y="2331720"/>
+            <a:ext cx="11091672" cy="749808"/>
+          </a:xfrm>
+          <a:prstGeom prst="roundRect">
+            <a:avLst>
+              <a:gd name="adj" fmla="val 6098"/>
+            </a:avLst>
+          </a:prstGeom>
+          <a:solidFill>
+            <a:srgbClr val="FBF6EE">
+              <a:alpha val="10000"/>
+            </a:srgbClr>
+          </a:solidFill>
+          <a:ln w="9525">
             <a:solidFill>
               <a:srgbClr val="BAA898"/>
             </a:solidFill>
@@ -4156,24 +4273,184 @@
       </p:sp>
       <p:sp>
         <p:nvSpPr>
-          <p:cNvPr id="5" name="Shape 3"/>
+          <p:cNvPr id="10" name="Text 8"/>
+          <p:cNvSpPr txBox="1"/>
+          <p:nvPr/>
+        </p:nvSpPr>
+        <p:spPr>
+          <a:xfrm>
+            <a:off x="822960" y="2331720"/>
+            <a:ext cx="1554480" cy="749808"/>
+          </a:xfrm>
+          <a:prstGeom prst="rect">
+            <a:avLst/>
+          </a:prstGeom>
+          <a:noFill/>
+          <a:ln/>
+        </p:spPr>
+        <p:txBody>
+          <a:bodyPr wrap="square" lIns="0" tIns="0" rIns="0" bIns="0" rtlCol="0" anchor="ctr"/>
+          <a:lstStyle/>
+          <a:p>
+            <a:pPr indent="0" marL="0">
+              <a:buNone/>
+            </a:pPr>
+            <a:r>
+              <a:rPr lang="en-US" sz="1300" b="1" dirty="0">
+                <a:solidFill>
+                  <a:srgbClr val="EEE0CB"/>
+                </a:solidFill>
+                <a:latin typeface="IBM Plex Serif" pitchFamily="34" charset="0"/>
+                <a:ea typeface="IBM Plex Serif" pitchFamily="34" charset="-122"/>
+                <a:cs typeface="IBM Plex Serif" pitchFamily="34" charset="-120"/>
+              </a:rPr>
+              <a:t>Negocio</a:t>
+            </a:r>
+            <a:endParaRPr lang="en-US" sz="1300" dirty="0"/>
+          </a:p>
+        </p:txBody>
+      </p:sp>
+      <p:sp>
+        <p:nvSpPr>
+          <p:cNvPr id="11" name="Text 9"/>
+          <p:cNvSpPr txBox="1"/>
+          <p:nvPr/>
+        </p:nvSpPr>
+        <p:spPr>
+          <a:xfrm>
+            <a:off x="2468880" y="2331720"/>
+            <a:ext cx="3566160" cy="749808"/>
+          </a:xfrm>
+          <a:prstGeom prst="rect">
+            <a:avLst/>
+          </a:prstGeom>
+          <a:noFill/>
+          <a:ln/>
+        </p:spPr>
+        <p:txBody>
+          <a:bodyPr wrap="square" lIns="0" tIns="0" rIns="0" bIns="0" rtlCol="0" anchor="ctr"/>
+          <a:lstStyle/>
+          <a:p>
+            <a:pPr indent="0" marL="0">
+              <a:buNone/>
+            </a:pPr>
+            <a:r>
+              <a:rPr lang="en-US" sz="1100" dirty="0">
+                <a:solidFill>
+                  <a:srgbClr val="EEE0CB"/>
+                </a:solidFill>
+                <a:latin typeface="Poppins" pitchFamily="34" charset="0"/>
+                <a:ea typeface="Poppins" pitchFamily="34" charset="-122"/>
+                <a:cs typeface="Poppins" pitchFamily="34" charset="-120"/>
+              </a:rPr>
+              <a:t>Mapa de procesos actual</a:t>
+            </a:r>
+            <a:endParaRPr lang="en-US" sz="1100" dirty="0"/>
+          </a:p>
+        </p:txBody>
+      </p:sp>
+      <p:sp>
+        <p:nvSpPr>
+          <p:cNvPr id="12" name="Text 10"/>
+          <p:cNvSpPr txBox="1"/>
+          <p:nvPr/>
+        </p:nvSpPr>
+        <p:spPr>
+          <a:xfrm>
+            <a:off x="6080760" y="2331720"/>
+            <a:ext cx="457200" cy="749808"/>
+          </a:xfrm>
+          <a:prstGeom prst="rect">
+            <a:avLst/>
+          </a:prstGeom>
+          <a:noFill/>
+          <a:ln/>
+        </p:spPr>
+        <p:txBody>
+          <a:bodyPr wrap="square" lIns="0" tIns="0" rIns="0" bIns="0" rtlCol="0" anchor="ctr"/>
+          <a:lstStyle/>
+          <a:p>
+            <a:pPr algn="ctr" indent="0" marL="0">
+              <a:buNone/>
+            </a:pPr>
+            <a:r>
+              <a:rPr lang="en-US" sz="1400" b="1" dirty="0">
+                <a:solidFill>
+                  <a:srgbClr val="C2847A"/>
+                </a:solidFill>
+                <a:latin typeface="Poppins" pitchFamily="34" charset="0"/>
+                <a:ea typeface="Poppins" pitchFamily="34" charset="-122"/>
+                <a:cs typeface="Poppins" pitchFamily="34" charset="-120"/>
+              </a:rPr>
+              <a:t>→</a:t>
+            </a:r>
+            <a:endParaRPr lang="en-US" sz="1400" dirty="0"/>
+          </a:p>
+        </p:txBody>
+      </p:sp>
+      <p:sp>
+        <p:nvSpPr>
+          <p:cNvPr id="13" name="Text 11"/>
+          <p:cNvSpPr txBox="1"/>
+          <p:nvPr/>
+        </p:nvSpPr>
+        <p:spPr>
+          <a:xfrm>
+            <a:off x="6629400" y="2331720"/>
+            <a:ext cx="4754880" cy="749808"/>
+          </a:xfrm>
+          <a:prstGeom prst="rect">
+            <a:avLst/>
+          </a:prstGeom>
+          <a:noFill/>
+          <a:ln/>
+        </p:spPr>
+        <p:txBody>
+          <a:bodyPr wrap="square" lIns="0" tIns="0" rIns="0" bIns="0" rtlCol="0" anchor="ctr"/>
+          <a:lstStyle/>
+          <a:p>
+            <a:pPr indent="0" marL="0">
+              <a:buNone/>
+            </a:pPr>
+            <a:r>
+              <a:rPr lang="en-US" sz="1100" dirty="0">
+                <a:solidFill>
+                  <a:srgbClr val="EEE0CB"/>
+                </a:solidFill>
+                <a:latin typeface="Poppins" pitchFamily="34" charset="0"/>
+                <a:ea typeface="Poppins" pitchFamily="34" charset="-122"/>
+                <a:cs typeface="Poppins" pitchFamily="34" charset="-120"/>
+              </a:rPr>
+              <a:t>Procesos rediseñados para la transformación</a:t>
+            </a:r>
+            <a:endParaRPr lang="en-US" sz="1100" dirty="0"/>
+          </a:p>
+        </p:txBody>
+      </p:sp>
+      <p:sp>
+        <p:nvSpPr>
+          <p:cNvPr id="14" name="Shape 12"/>
           <p:cNvSpPr/>
           <p:nvPr/>
         </p:nvSpPr>
         <p:spPr>
           <a:xfrm>
-            <a:off x="822960" y="2971800"/>
-            <a:ext cx="640080" cy="640080"/>
-          </a:xfrm>
-          <a:prstGeom prst="ellipse">
-            <a:avLst/>
+            <a:off x="548640" y="3163824"/>
+            <a:ext cx="11091672" cy="749808"/>
+          </a:xfrm>
+          <a:prstGeom prst="roundRect">
+            <a:avLst>
+              <a:gd name="adj" fmla="val 6098"/>
+            </a:avLst>
           </a:prstGeom>
           <a:solidFill>
-            <a:srgbClr val="C2847A"/>
+            <a:srgbClr val="FBF6EE">
+              <a:alpha val="10000"/>
+            </a:srgbClr>
           </a:solidFill>
-          <a:ln w="19050">
+          <a:ln w="9525">
             <a:solidFill>
-              <a:srgbClr val="EEE0CB"/>
+              <a:srgbClr val="BAA898"/>
             </a:solidFill>
             <a:prstDash val="solid"/>
           </a:ln>
@@ -4181,14 +4458,92 @@
       </p:sp>
       <p:sp>
         <p:nvSpPr>
-          <p:cNvPr id="6" name="Text 4"/>
-          <p:cNvSpPr txBox="1"/>
-          <p:nvPr/>
-        </p:nvSpPr>
-        <p:spPr>
-          <a:xfrm>
-            <a:off x="822960" y="2971800"/>
-            <a:ext cx="640080" cy="640080"/>
+          <p:cNvPr id="15" name="Text 13"/>
+          <p:cNvSpPr txBox="1"/>
+          <p:nvPr/>
+        </p:nvSpPr>
+        <p:spPr>
+          <a:xfrm>
+            <a:off x="822960" y="3163824"/>
+            <a:ext cx="1554480" cy="749808"/>
+          </a:xfrm>
+          <a:prstGeom prst="rect">
+            <a:avLst/>
+          </a:prstGeom>
+          <a:noFill/>
+          <a:ln/>
+        </p:spPr>
+        <p:txBody>
+          <a:bodyPr wrap="square" lIns="0" tIns="0" rIns="0" bIns="0" rtlCol="0" anchor="ctr"/>
+          <a:lstStyle/>
+          <a:p>
+            <a:pPr indent="0" marL="0">
+              <a:buNone/>
+            </a:pPr>
+            <a:r>
+              <a:rPr lang="en-US" sz="1300" b="1" dirty="0">
+                <a:solidFill>
+                  <a:srgbClr val="EEE0CB"/>
+                </a:solidFill>
+                <a:latin typeface="IBM Plex Serif" pitchFamily="34" charset="0"/>
+                <a:ea typeface="IBM Plex Serif" pitchFamily="34" charset="-122"/>
+                <a:cs typeface="IBM Plex Serif" pitchFamily="34" charset="-120"/>
+              </a:rPr>
+              <a:t>Datos</a:t>
+            </a:r>
+            <a:endParaRPr lang="en-US" sz="1300" dirty="0"/>
+          </a:p>
+        </p:txBody>
+      </p:sp>
+      <p:sp>
+        <p:nvSpPr>
+          <p:cNvPr id="16" name="Text 14"/>
+          <p:cNvSpPr txBox="1"/>
+          <p:nvPr/>
+        </p:nvSpPr>
+        <p:spPr>
+          <a:xfrm>
+            <a:off x="2468880" y="3163824"/>
+            <a:ext cx="3566160" cy="749808"/>
+          </a:xfrm>
+          <a:prstGeom prst="rect">
+            <a:avLst/>
+          </a:prstGeom>
+          <a:noFill/>
+          <a:ln/>
+        </p:spPr>
+        <p:txBody>
+          <a:bodyPr wrap="square" lIns="0" tIns="0" rIns="0" bIns="0" rtlCol="0" anchor="ctr"/>
+          <a:lstStyle/>
+          <a:p>
+            <a:pPr indent="0" marL="0">
+              <a:buNone/>
+            </a:pPr>
+            <a:r>
+              <a:rPr lang="en-US" sz="1100" dirty="0">
+                <a:solidFill>
+                  <a:srgbClr val="EEE0CB"/>
+                </a:solidFill>
+                <a:latin typeface="Poppins" pitchFamily="34" charset="0"/>
+                <a:ea typeface="Poppins" pitchFamily="34" charset="-122"/>
+                <a:cs typeface="Poppins" pitchFamily="34" charset="-120"/>
+              </a:rPr>
+              <a:t>Bases y fuentes de datos actuales</a:t>
+            </a:r>
+            <a:endParaRPr lang="en-US" sz="1100" dirty="0"/>
+          </a:p>
+        </p:txBody>
+      </p:sp>
+      <p:sp>
+        <p:nvSpPr>
+          <p:cNvPr id="17" name="Text 15"/>
+          <p:cNvSpPr txBox="1"/>
+          <p:nvPr/>
+        </p:nvSpPr>
+        <p:spPr>
+          <a:xfrm>
+            <a:off x="6080760" y="3163824"/>
+            <a:ext cx="457200" cy="749808"/>
           </a:xfrm>
           <a:prstGeom prst="rect">
             <a:avLst/>
@@ -4204,15 +4559,54 @@
               <a:buNone/>
             </a:pPr>
             <a:r>
-              <a:rPr lang="en-US" sz="1100" b="1" dirty="0">
-                <a:solidFill>
-                  <a:srgbClr val="FFFFFF"/>
-                </a:solidFill>
-                <a:latin typeface="Poppins" pitchFamily="34" charset="0"/>
-                <a:ea typeface="Poppins" pitchFamily="34" charset="-122"/>
-                <a:cs typeface="Poppins" pitchFamily="34" charset="-120"/>
-              </a:rPr>
-              <a:t>T-03</a:t>
+              <a:rPr lang="en-US" sz="1400" b="1" dirty="0">
+                <a:solidFill>
+                  <a:srgbClr val="C2847A"/>
+                </a:solidFill>
+                <a:latin typeface="Poppins" pitchFamily="34" charset="0"/>
+                <a:ea typeface="Poppins" pitchFamily="34" charset="-122"/>
+                <a:cs typeface="Poppins" pitchFamily="34" charset="-120"/>
+              </a:rPr>
+              <a:t>→</a:t>
+            </a:r>
+            <a:endParaRPr lang="en-US" sz="1400" dirty="0"/>
+          </a:p>
+        </p:txBody>
+      </p:sp>
+      <p:sp>
+        <p:nvSpPr>
+          <p:cNvPr id="18" name="Text 16"/>
+          <p:cNvSpPr txBox="1"/>
+          <p:nvPr/>
+        </p:nvSpPr>
+        <p:spPr>
+          <a:xfrm>
+            <a:off x="6629400" y="3163824"/>
+            <a:ext cx="4754880" cy="749808"/>
+          </a:xfrm>
+          <a:prstGeom prst="rect">
+            <a:avLst/>
+          </a:prstGeom>
+          <a:noFill/>
+          <a:ln/>
+        </p:spPr>
+        <p:txBody>
+          <a:bodyPr wrap="square" lIns="0" tIns="0" rIns="0" bIns="0" rtlCol="0" anchor="ctr"/>
+          <a:lstStyle/>
+          <a:p>
+            <a:pPr indent="0" marL="0">
+              <a:buNone/>
+            </a:pPr>
+            <a:r>
+              <a:rPr lang="en-US" sz="1100" dirty="0">
+                <a:solidFill>
+                  <a:srgbClr val="EEE0CB"/>
+                </a:solidFill>
+                <a:latin typeface="Poppins" pitchFamily="34" charset="0"/>
+                <a:ea typeface="Poppins" pitchFamily="34" charset="-122"/>
+                <a:cs typeface="Poppins" pitchFamily="34" charset="-120"/>
+              </a:rPr>
+              <a:t>Capacidades de datos que necesita el destino</a:t>
             </a:r>
             <a:endParaRPr lang="en-US" sz="1100" dirty="0"/>
           </a:p>
@@ -4220,102 +4614,28 @@
       </p:sp>
       <p:sp>
         <p:nvSpPr>
-          <p:cNvPr id="7" name="Text 5"/>
-          <p:cNvSpPr txBox="1"/>
-          <p:nvPr/>
-        </p:nvSpPr>
-        <p:spPr>
-          <a:xfrm>
-            <a:off x="457200" y="3749040"/>
-            <a:ext cx="1645920" cy="274320"/>
-          </a:xfrm>
-          <a:prstGeom prst="rect">
-            <a:avLst/>
-          </a:prstGeom>
-          <a:noFill/>
-          <a:ln/>
-        </p:spPr>
-        <p:txBody>
-          <a:bodyPr wrap="square" lIns="0" tIns="0" rIns="0" bIns="0" rtlCol="0" anchor="ctr"/>
-          <a:lstStyle/>
-          <a:p>
-            <a:pPr algn="ctr" indent="0" marL="0">
-              <a:buNone/>
-            </a:pPr>
-            <a:r>
-              <a:rPr lang="en-US" sz="1200" b="1" dirty="0">
-                <a:solidFill>
-                  <a:srgbClr val="C2847A"/>
-                </a:solidFill>
-                <a:latin typeface="Poppins" pitchFamily="34" charset="0"/>
-                <a:ea typeface="Poppins" pitchFamily="34" charset="-122"/>
-                <a:cs typeface="Poppins" pitchFamily="34" charset="-120"/>
-              </a:rPr>
-              <a:t>10/09</a:t>
-            </a:r>
-            <a:endParaRPr lang="en-US" sz="1200" dirty="0"/>
-          </a:p>
-        </p:txBody>
-      </p:sp>
-      <p:sp>
-        <p:nvSpPr>
-          <p:cNvPr id="8" name="Text 6"/>
-          <p:cNvSpPr txBox="1"/>
-          <p:nvPr/>
-        </p:nvSpPr>
-        <p:spPr>
-          <a:xfrm>
-            <a:off x="457200" y="4069080"/>
-            <a:ext cx="2103120" cy="1005840"/>
-          </a:xfrm>
-          <a:prstGeom prst="rect">
-            <a:avLst/>
-          </a:prstGeom>
-          <a:noFill/>
-          <a:ln/>
-        </p:spPr>
-        <p:txBody>
-          <a:bodyPr wrap="square" lIns="0" tIns="0" rIns="0" bIns="0" rtlCol="0" anchor="t"/>
-          <a:lstStyle/>
-          <a:p>
-            <a:pPr algn="ctr" indent="0" marL="0">
-              <a:buNone/>
-            </a:pPr>
-            <a:r>
-              <a:rPr lang="en-US" sz="1200" dirty="0">
-                <a:solidFill>
-                  <a:srgbClr val="EEE0CB"/>
-                </a:solidFill>
-                <a:latin typeface="Poppins" pitchFamily="34" charset="0"/>
-                <a:ea typeface="Poppins" pitchFamily="34" charset="-122"/>
-                <a:cs typeface="Poppins" pitchFamily="34" charset="-120"/>
-              </a:rPr>
-              <a:t>Visión de Arquitectura Destino</a:t>
-            </a:r>
-            <a:endParaRPr lang="en-US" sz="1200" dirty="0"/>
-          </a:p>
-        </p:txBody>
-      </p:sp>
-      <p:sp>
-        <p:nvSpPr>
-          <p:cNvPr id="9" name="Shape 7"/>
+          <p:cNvPr id="19" name="Shape 17"/>
           <p:cNvSpPr/>
           <p:nvPr/>
         </p:nvSpPr>
         <p:spPr>
           <a:xfrm>
-            <a:off x="4343400" y="2971800"/>
-            <a:ext cx="640080" cy="640080"/>
-          </a:xfrm>
-          <a:prstGeom prst="ellipse">
-            <a:avLst/>
+            <a:off x="548640" y="3995928"/>
+            <a:ext cx="11091672" cy="749808"/>
+          </a:xfrm>
+          <a:prstGeom prst="roundRect">
+            <a:avLst>
+              <a:gd name="adj" fmla="val 6098"/>
+            </a:avLst>
           </a:prstGeom>
           <a:solidFill>
-            <a:srgbClr val="6B2737"/>
+            <a:srgbClr val="FBF6EE">
+              <a:alpha val="10000"/>
+            </a:srgbClr>
           </a:solidFill>
-          <a:ln w="19050">
+          <a:ln w="9525">
             <a:solidFill>
-              <a:srgbClr val="EEE0CB"/>
+              <a:srgbClr val="BAA898"/>
             </a:solidFill>
             <a:prstDash val="solid"/>
           </a:ln>
@@ -4323,14 +4643,92 @@
       </p:sp>
       <p:sp>
         <p:nvSpPr>
-          <p:cNvPr id="10" name="Text 8"/>
-          <p:cNvSpPr txBox="1"/>
-          <p:nvPr/>
-        </p:nvSpPr>
-        <p:spPr>
-          <a:xfrm>
-            <a:off x="4343400" y="2971800"/>
-            <a:ext cx="640080" cy="640080"/>
+          <p:cNvPr id="20" name="Text 18"/>
+          <p:cNvSpPr txBox="1"/>
+          <p:nvPr/>
+        </p:nvSpPr>
+        <p:spPr>
+          <a:xfrm>
+            <a:off x="822960" y="3995928"/>
+            <a:ext cx="1554480" cy="749808"/>
+          </a:xfrm>
+          <a:prstGeom prst="rect">
+            <a:avLst/>
+          </a:prstGeom>
+          <a:noFill/>
+          <a:ln/>
+        </p:spPr>
+        <p:txBody>
+          <a:bodyPr wrap="square" lIns="0" tIns="0" rIns="0" bIns="0" rtlCol="0" anchor="ctr"/>
+          <a:lstStyle/>
+          <a:p>
+            <a:pPr indent="0" marL="0">
+              <a:buNone/>
+            </a:pPr>
+            <a:r>
+              <a:rPr lang="en-US" sz="1300" b="1" dirty="0">
+                <a:solidFill>
+                  <a:srgbClr val="EEE0CB"/>
+                </a:solidFill>
+                <a:latin typeface="IBM Plex Serif" pitchFamily="34" charset="0"/>
+                <a:ea typeface="IBM Plex Serif" pitchFamily="34" charset="-122"/>
+                <a:cs typeface="IBM Plex Serif" pitchFamily="34" charset="-120"/>
+              </a:rPr>
+              <a:t>Aplicaciones</a:t>
+            </a:r>
+            <a:endParaRPr lang="en-US" sz="1300" dirty="0"/>
+          </a:p>
+        </p:txBody>
+      </p:sp>
+      <p:sp>
+        <p:nvSpPr>
+          <p:cNvPr id="21" name="Text 19"/>
+          <p:cNvSpPr txBox="1"/>
+          <p:nvPr/>
+        </p:nvSpPr>
+        <p:spPr>
+          <a:xfrm>
+            <a:off x="2468880" y="3995928"/>
+            <a:ext cx="3566160" cy="749808"/>
+          </a:xfrm>
+          <a:prstGeom prst="rect">
+            <a:avLst/>
+          </a:prstGeom>
+          <a:noFill/>
+          <a:ln/>
+        </p:spPr>
+        <p:txBody>
+          <a:bodyPr wrap="square" lIns="0" tIns="0" rIns="0" bIns="0" rtlCol="0" anchor="ctr"/>
+          <a:lstStyle/>
+          <a:p>
+            <a:pPr indent="0" marL="0">
+              <a:buNone/>
+            </a:pPr>
+            <a:r>
+              <a:rPr lang="en-US" sz="1100" dirty="0">
+                <a:solidFill>
+                  <a:srgbClr val="EEE0CB"/>
+                </a:solidFill>
+                <a:latin typeface="Poppins" pitchFamily="34" charset="0"/>
+                <a:ea typeface="Poppins" pitchFamily="34" charset="-122"/>
+                <a:cs typeface="Poppins" pitchFamily="34" charset="-120"/>
+              </a:rPr>
+              <a:t>Catálogo de aplicaciones actual</a:t>
+            </a:r>
+            <a:endParaRPr lang="en-US" sz="1100" dirty="0"/>
+          </a:p>
+        </p:txBody>
+      </p:sp>
+      <p:sp>
+        <p:nvSpPr>
+          <p:cNvPr id="22" name="Text 20"/>
+          <p:cNvSpPr txBox="1"/>
+          <p:nvPr/>
+        </p:nvSpPr>
+        <p:spPr>
+          <a:xfrm>
+            <a:off x="6080760" y="3995928"/>
+            <a:ext cx="457200" cy="749808"/>
           </a:xfrm>
           <a:prstGeom prst="rect">
             <a:avLst/>
@@ -4346,15 +4744,54 @@
               <a:buNone/>
             </a:pPr>
             <a:r>
-              <a:rPr lang="en-US" sz="1100" b="1" dirty="0">
-                <a:solidFill>
-                  <a:srgbClr val="FFFFFF"/>
-                </a:solidFill>
-                <a:latin typeface="Poppins" pitchFamily="34" charset="0"/>
-                <a:ea typeface="Poppins" pitchFamily="34" charset="-122"/>
-                <a:cs typeface="Poppins" pitchFamily="34" charset="-120"/>
-              </a:rPr>
-              <a:t>T-04</a:t>
+              <a:rPr lang="en-US" sz="1400" b="1" dirty="0">
+                <a:solidFill>
+                  <a:srgbClr val="C2847A"/>
+                </a:solidFill>
+                <a:latin typeface="Poppins" pitchFamily="34" charset="0"/>
+                <a:ea typeface="Poppins" pitchFamily="34" charset="-122"/>
+                <a:cs typeface="Poppins" pitchFamily="34" charset="-120"/>
+              </a:rPr>
+              <a:t>→</a:t>
+            </a:r>
+            <a:endParaRPr lang="en-US" sz="1400" dirty="0"/>
+          </a:p>
+        </p:txBody>
+      </p:sp>
+      <p:sp>
+        <p:nvSpPr>
+          <p:cNvPr id="23" name="Text 21"/>
+          <p:cNvSpPr txBox="1"/>
+          <p:nvPr/>
+        </p:nvSpPr>
+        <p:spPr>
+          <a:xfrm>
+            <a:off x="6629400" y="3995928"/>
+            <a:ext cx="4754880" cy="749808"/>
+          </a:xfrm>
+          <a:prstGeom prst="rect">
+            <a:avLst/>
+          </a:prstGeom>
+          <a:noFill/>
+          <a:ln/>
+        </p:spPr>
+        <p:txBody>
+          <a:bodyPr wrap="square" lIns="0" tIns="0" rIns="0" bIns="0" rtlCol="0" anchor="ctr"/>
+          <a:lstStyle/>
+          <a:p>
+            <a:pPr indent="0" marL="0">
+              <a:buNone/>
+            </a:pPr>
+            <a:r>
+              <a:rPr lang="en-US" sz="1100" dirty="0">
+                <a:solidFill>
+                  <a:srgbClr val="EEE0CB"/>
+                </a:solidFill>
+                <a:latin typeface="Poppins" pitchFamily="34" charset="0"/>
+                <a:ea typeface="Poppins" pitchFamily="34" charset="-122"/>
+                <a:cs typeface="Poppins" pitchFamily="34" charset="-120"/>
+              </a:rPr>
+              <a:t>Aplicaciones y servicios que deberían existir</a:t>
             </a:r>
             <a:endParaRPr lang="en-US" sz="1100" dirty="0"/>
           </a:p>
@@ -4362,102 +4799,28 @@
       </p:sp>
       <p:sp>
         <p:nvSpPr>
-          <p:cNvPr id="11" name="Text 9"/>
-          <p:cNvSpPr txBox="1"/>
-          <p:nvPr/>
-        </p:nvSpPr>
-        <p:spPr>
-          <a:xfrm>
-            <a:off x="3840480" y="3749040"/>
-            <a:ext cx="1645920" cy="274320"/>
-          </a:xfrm>
-          <a:prstGeom prst="rect">
-            <a:avLst/>
-          </a:prstGeom>
-          <a:noFill/>
-          <a:ln/>
-        </p:spPr>
-        <p:txBody>
-          <a:bodyPr wrap="square" lIns="0" tIns="0" rIns="0" bIns="0" rtlCol="0" anchor="ctr"/>
-          <a:lstStyle/>
-          <a:p>
-            <a:pPr algn="ctr" indent="0" marL="0">
-              <a:buNone/>
-            </a:pPr>
-            <a:r>
-              <a:rPr lang="en-US" sz="1200" b="1" dirty="0">
-                <a:solidFill>
-                  <a:srgbClr val="C2847A"/>
-                </a:solidFill>
-                <a:latin typeface="Poppins" pitchFamily="34" charset="0"/>
-                <a:ea typeface="Poppins" pitchFamily="34" charset="-122"/>
-                <a:cs typeface="Poppins" pitchFamily="34" charset="-120"/>
-              </a:rPr>
-              <a:t>17/09</a:t>
-            </a:r>
-            <a:endParaRPr lang="en-US" sz="1200" dirty="0"/>
-          </a:p>
-        </p:txBody>
-      </p:sp>
-      <p:sp>
-        <p:nvSpPr>
-          <p:cNvPr id="12" name="Text 10"/>
-          <p:cNvSpPr txBox="1"/>
-          <p:nvPr/>
-        </p:nvSpPr>
-        <p:spPr>
-          <a:xfrm>
-            <a:off x="3611880" y="4069080"/>
-            <a:ext cx="2103120" cy="1005840"/>
-          </a:xfrm>
-          <a:prstGeom prst="rect">
-            <a:avLst/>
-          </a:prstGeom>
-          <a:noFill/>
-          <a:ln/>
-        </p:spPr>
-        <p:txBody>
-          <a:bodyPr wrap="square" lIns="0" tIns="0" rIns="0" bIns="0" rtlCol="0" anchor="t"/>
-          <a:lstStyle/>
-          <a:p>
-            <a:pPr algn="ctr" indent="0" marL="0">
-              <a:buNone/>
-            </a:pPr>
-            <a:r>
-              <a:rPr lang="en-US" sz="1200" dirty="0">
-                <a:solidFill>
-                  <a:srgbClr val="EEE0CB"/>
-                </a:solidFill>
-                <a:latin typeface="Poppins" pitchFamily="34" charset="0"/>
-                <a:ea typeface="Poppins" pitchFamily="34" charset="-122"/>
-                <a:cs typeface="Poppins" pitchFamily="34" charset="-120"/>
-              </a:rPr>
-              <a:t>Matriz de Brechas y Escenarios</a:t>
-            </a:r>
-            <a:endParaRPr lang="en-US" sz="1200" dirty="0"/>
-          </a:p>
-        </p:txBody>
-      </p:sp>
-      <p:sp>
-        <p:nvSpPr>
-          <p:cNvPr id="13" name="Shape 11"/>
+          <p:cNvPr id="24" name="Shape 22"/>
           <p:cNvSpPr/>
           <p:nvPr/>
         </p:nvSpPr>
         <p:spPr>
           <a:xfrm>
-            <a:off x="7863840" y="2971800"/>
-            <a:ext cx="640080" cy="640080"/>
-          </a:xfrm>
-          <a:prstGeom prst="ellipse">
-            <a:avLst/>
+            <a:off x="548640" y="4828032"/>
+            <a:ext cx="11091672" cy="749808"/>
+          </a:xfrm>
+          <a:prstGeom prst="roundRect">
+            <a:avLst>
+              <a:gd name="adj" fmla="val 6098"/>
+            </a:avLst>
           </a:prstGeom>
           <a:solidFill>
-            <a:srgbClr val="6B2737"/>
+            <a:srgbClr val="FBF6EE">
+              <a:alpha val="10000"/>
+            </a:srgbClr>
           </a:solidFill>
-          <a:ln w="19050">
+          <a:ln w="9525">
             <a:solidFill>
-              <a:srgbClr val="EEE0CB"/>
+              <a:srgbClr val="BAA898"/>
             </a:solidFill>
             <a:prstDash val="solid"/>
           </a:ln>
@@ -4465,14 +4828,92 @@
       </p:sp>
       <p:sp>
         <p:nvSpPr>
-          <p:cNvPr id="14" name="Text 12"/>
-          <p:cNvSpPr txBox="1"/>
-          <p:nvPr/>
-        </p:nvSpPr>
-        <p:spPr>
-          <a:xfrm>
-            <a:off x="7863840" y="2971800"/>
-            <a:ext cx="640080" cy="640080"/>
+          <p:cNvPr id="25" name="Text 23"/>
+          <p:cNvSpPr txBox="1"/>
+          <p:nvPr/>
+        </p:nvSpPr>
+        <p:spPr>
+          <a:xfrm>
+            <a:off x="822960" y="4828032"/>
+            <a:ext cx="1554480" cy="749808"/>
+          </a:xfrm>
+          <a:prstGeom prst="rect">
+            <a:avLst/>
+          </a:prstGeom>
+          <a:noFill/>
+          <a:ln/>
+        </p:spPr>
+        <p:txBody>
+          <a:bodyPr wrap="square" lIns="0" tIns="0" rIns="0" bIns="0" rtlCol="0" anchor="ctr"/>
+          <a:lstStyle/>
+          <a:p>
+            <a:pPr indent="0" marL="0">
+              <a:buNone/>
+            </a:pPr>
+            <a:r>
+              <a:rPr lang="en-US" sz="1300" b="1" dirty="0">
+                <a:solidFill>
+                  <a:srgbClr val="EEE0CB"/>
+                </a:solidFill>
+                <a:latin typeface="IBM Plex Serif" pitchFamily="34" charset="0"/>
+                <a:ea typeface="IBM Plex Serif" pitchFamily="34" charset="-122"/>
+                <a:cs typeface="IBM Plex Serif" pitchFamily="34" charset="-120"/>
+              </a:rPr>
+              <a:t>Tecnología</a:t>
+            </a:r>
+            <a:endParaRPr lang="en-US" sz="1300" dirty="0"/>
+          </a:p>
+        </p:txBody>
+      </p:sp>
+      <p:sp>
+        <p:nvSpPr>
+          <p:cNvPr id="26" name="Text 24"/>
+          <p:cNvSpPr txBox="1"/>
+          <p:nvPr/>
+        </p:nvSpPr>
+        <p:spPr>
+          <a:xfrm>
+            <a:off x="2468880" y="4828032"/>
+            <a:ext cx="3566160" cy="749808"/>
+          </a:xfrm>
+          <a:prstGeom prst="rect">
+            <a:avLst/>
+          </a:prstGeom>
+          <a:noFill/>
+          <a:ln/>
+        </p:spPr>
+        <p:txBody>
+          <a:bodyPr wrap="square" lIns="0" tIns="0" rIns="0" bIns="0" rtlCol="0" anchor="ctr"/>
+          <a:lstStyle/>
+          <a:p>
+            <a:pPr indent="0" marL="0">
+              <a:buNone/>
+            </a:pPr>
+            <a:r>
+              <a:rPr lang="en-US" sz="1100" dirty="0">
+                <a:solidFill>
+                  <a:srgbClr val="EEE0CB"/>
+                </a:solidFill>
+                <a:latin typeface="Poppins" pitchFamily="34" charset="0"/>
+                <a:ea typeface="Poppins" pitchFamily="34" charset="-122"/>
+                <a:cs typeface="Poppins" pitchFamily="34" charset="-120"/>
+              </a:rPr>
+              <a:t>Infraestructura y tecnología actual</a:t>
+            </a:r>
+            <a:endParaRPr lang="en-US" sz="1100" dirty="0"/>
+          </a:p>
+        </p:txBody>
+      </p:sp>
+      <p:sp>
+        <p:nvSpPr>
+          <p:cNvPr id="27" name="Text 25"/>
+          <p:cNvSpPr txBox="1"/>
+          <p:nvPr/>
+        </p:nvSpPr>
+        <p:spPr>
+          <a:xfrm>
+            <a:off x="6080760" y="4828032"/>
+            <a:ext cx="457200" cy="749808"/>
           </a:xfrm>
           <a:prstGeom prst="rect">
             <a:avLst/>
@@ -4488,15 +4929,54 @@
               <a:buNone/>
             </a:pPr>
             <a:r>
-              <a:rPr lang="en-US" sz="1100" b="1" dirty="0">
-                <a:solidFill>
-                  <a:srgbClr val="FFFFFF"/>
-                </a:solidFill>
-                <a:latin typeface="Poppins" pitchFamily="34" charset="0"/>
-                <a:ea typeface="Poppins" pitchFamily="34" charset="-122"/>
-                <a:cs typeface="Poppins" pitchFamily="34" charset="-120"/>
-              </a:rPr>
-              <a:t>—</a:t>
+              <a:rPr lang="en-US" sz="1400" b="1" dirty="0">
+                <a:solidFill>
+                  <a:srgbClr val="C2847A"/>
+                </a:solidFill>
+                <a:latin typeface="Poppins" pitchFamily="34" charset="0"/>
+                <a:ea typeface="Poppins" pitchFamily="34" charset="-122"/>
+                <a:cs typeface="Poppins" pitchFamily="34" charset="-120"/>
+              </a:rPr>
+              <a:t>→</a:t>
+            </a:r>
+            <a:endParaRPr lang="en-US" sz="1400" dirty="0"/>
+          </a:p>
+        </p:txBody>
+      </p:sp>
+      <p:sp>
+        <p:nvSpPr>
+          <p:cNvPr id="28" name="Text 26"/>
+          <p:cNvSpPr txBox="1"/>
+          <p:nvPr/>
+        </p:nvSpPr>
+        <p:spPr>
+          <a:xfrm>
+            <a:off x="6629400" y="4828032"/>
+            <a:ext cx="4754880" cy="749808"/>
+          </a:xfrm>
+          <a:prstGeom prst="rect">
+            <a:avLst/>
+          </a:prstGeom>
+          <a:noFill/>
+          <a:ln/>
+        </p:spPr>
+        <p:txBody>
+          <a:bodyPr wrap="square" lIns="0" tIns="0" rIns="0" bIns="0" rtlCol="0" anchor="ctr"/>
+          <a:lstStyle/>
+          <a:p>
+            <a:pPr indent="0" marL="0">
+              <a:buNone/>
+            </a:pPr>
+            <a:r>
+              <a:rPr lang="en-US" sz="1100" dirty="0">
+                <a:solidFill>
+                  <a:srgbClr val="EEE0CB"/>
+                </a:solidFill>
+                <a:latin typeface="Poppins" pitchFamily="34" charset="0"/>
+                <a:ea typeface="Poppins" pitchFamily="34" charset="-122"/>
+                <a:cs typeface="Poppins" pitchFamily="34" charset="-120"/>
+              </a:rPr>
+              <a:t>Requerimientos y restricciones tecnológicas</a:t>
             </a:r>
             <a:endParaRPr lang="en-US" sz="1100" dirty="0"/>
           </a:p>
@@ -4504,227 +4984,7 @@
       </p:sp>
       <p:sp>
         <p:nvSpPr>
-          <p:cNvPr id="15" name="Text 13"/>
-          <p:cNvSpPr txBox="1"/>
-          <p:nvPr/>
-        </p:nvSpPr>
-        <p:spPr>
-          <a:xfrm>
-            <a:off x="7360920" y="3749040"/>
-            <a:ext cx="1645920" cy="274320"/>
-          </a:xfrm>
-          <a:prstGeom prst="rect">
-            <a:avLst/>
-          </a:prstGeom>
-          <a:noFill/>
-          <a:ln/>
-        </p:spPr>
-        <p:txBody>
-          <a:bodyPr wrap="square" lIns="0" tIns="0" rIns="0" bIns="0" rtlCol="0" anchor="ctr"/>
-          <a:lstStyle/>
-          <a:p>
-            <a:pPr algn="ctr" indent="0" marL="0">
-              <a:buNone/>
-            </a:pPr>
-            <a:r>
-              <a:rPr lang="en-US" sz="1200" b="1" dirty="0">
-                <a:solidFill>
-                  <a:srgbClr val="C2847A"/>
-                </a:solidFill>
-                <a:latin typeface="Poppins" pitchFamily="34" charset="0"/>
-                <a:ea typeface="Poppins" pitchFamily="34" charset="-122"/>
-                <a:cs typeface="Poppins" pitchFamily="34" charset="-120"/>
-              </a:rPr>
-              <a:t>21/09</a:t>
-            </a:r>
-            <a:endParaRPr lang="en-US" sz="1200" dirty="0"/>
-          </a:p>
-        </p:txBody>
-      </p:sp>
-      <p:sp>
-        <p:nvSpPr>
-          <p:cNvPr id="16" name="Text 14"/>
-          <p:cNvSpPr txBox="1"/>
-          <p:nvPr/>
-        </p:nvSpPr>
-        <p:spPr>
-          <a:xfrm>
-            <a:off x="7132320" y="4069080"/>
-            <a:ext cx="2103120" cy="1005840"/>
-          </a:xfrm>
-          <a:prstGeom prst="rect">
-            <a:avLst/>
-          </a:prstGeom>
-          <a:noFill/>
-          <a:ln/>
-        </p:spPr>
-        <p:txBody>
-          <a:bodyPr wrap="square" lIns="0" tIns="0" rIns="0" bIns="0" rtlCol="0" anchor="t"/>
-          <a:lstStyle/>
-          <a:p>
-            <a:pPr algn="ctr" indent="0" marL="0">
-              <a:buNone/>
-            </a:pPr>
-            <a:r>
-              <a:rPr lang="en-US" sz="1200" dirty="0">
-                <a:solidFill>
-                  <a:srgbClr val="EEE0CB"/>
-                </a:solidFill>
-                <a:latin typeface="Poppins" pitchFamily="34" charset="0"/>
-                <a:ea typeface="Poppins" pitchFamily="34" charset="-122"/>
-                <a:cs typeface="Poppins" pitchFamily="34" charset="-120"/>
-              </a:rPr>
-              <a:t>Presentación de avance</a:t>
-            </a:r>
-            <a:endParaRPr lang="en-US" sz="1200" dirty="0"/>
-          </a:p>
-        </p:txBody>
-      </p:sp>
-      <p:sp>
-        <p:nvSpPr>
-          <p:cNvPr id="17" name="Shape 15"/>
-          <p:cNvSpPr/>
-          <p:nvPr/>
-        </p:nvSpPr>
-        <p:spPr>
-          <a:xfrm>
-            <a:off x="11384280" y="2971800"/>
-            <a:ext cx="640080" cy="640080"/>
-          </a:xfrm>
-          <a:prstGeom prst="ellipse">
-            <a:avLst/>
-          </a:prstGeom>
-          <a:solidFill>
-            <a:srgbClr val="6B2737"/>
-          </a:solidFill>
-          <a:ln w="19050">
-            <a:solidFill>
-              <a:srgbClr val="EEE0CB"/>
-            </a:solidFill>
-            <a:prstDash val="solid"/>
-          </a:ln>
-        </p:spPr>
-      </p:sp>
-      <p:sp>
-        <p:nvSpPr>
-          <p:cNvPr id="18" name="Text 16"/>
-          <p:cNvSpPr txBox="1"/>
-          <p:nvPr/>
-        </p:nvSpPr>
-        <p:spPr>
-          <a:xfrm>
-            <a:off x="11384280" y="2971800"/>
-            <a:ext cx="640080" cy="640080"/>
-          </a:xfrm>
-          <a:prstGeom prst="rect">
-            <a:avLst/>
-          </a:prstGeom>
-          <a:noFill/>
-          <a:ln/>
-        </p:spPr>
-        <p:txBody>
-          <a:bodyPr wrap="square" lIns="0" tIns="0" rIns="0" bIns="0" rtlCol="0" anchor="ctr"/>
-          <a:lstStyle/>
-          <a:p>
-            <a:pPr algn="ctr" indent="0" marL="0">
-              <a:buNone/>
-            </a:pPr>
-            <a:r>
-              <a:rPr lang="en-US" sz="1100" b="1" dirty="0">
-                <a:solidFill>
-                  <a:srgbClr val="FFFFFF"/>
-                </a:solidFill>
-                <a:latin typeface="Poppins" pitchFamily="34" charset="0"/>
-                <a:ea typeface="Poppins" pitchFamily="34" charset="-122"/>
-                <a:cs typeface="Poppins" pitchFamily="34" charset="-120"/>
-              </a:rPr>
-              <a:t>T-05</a:t>
-            </a:r>
-            <a:endParaRPr lang="en-US" sz="1100" dirty="0"/>
-          </a:p>
-        </p:txBody>
-      </p:sp>
-      <p:sp>
-        <p:nvSpPr>
-          <p:cNvPr id="19" name="Text 17"/>
-          <p:cNvSpPr txBox="1"/>
-          <p:nvPr/>
-        </p:nvSpPr>
-        <p:spPr>
-          <a:xfrm>
-            <a:off x="10088575" y="3749040"/>
-            <a:ext cx="1645920" cy="274320"/>
-          </a:xfrm>
-          <a:prstGeom prst="rect">
-            <a:avLst/>
-          </a:prstGeom>
-          <a:noFill/>
-          <a:ln/>
-        </p:spPr>
-        <p:txBody>
-          <a:bodyPr wrap="square" lIns="0" tIns="0" rIns="0" bIns="0" rtlCol="0" anchor="ctr"/>
-          <a:lstStyle/>
-          <a:p>
-            <a:pPr algn="ctr" indent="0" marL="0">
-              <a:buNone/>
-            </a:pPr>
-            <a:r>
-              <a:rPr lang="en-US" sz="1200" b="1" dirty="0">
-                <a:solidFill>
-                  <a:srgbClr val="C2847A"/>
-                </a:solidFill>
-                <a:latin typeface="Poppins" pitchFamily="34" charset="0"/>
-                <a:ea typeface="Poppins" pitchFamily="34" charset="-122"/>
-                <a:cs typeface="Poppins" pitchFamily="34" charset="-120"/>
-              </a:rPr>
-              <a:t>24/09</a:t>
-            </a:r>
-            <a:endParaRPr lang="en-US" sz="1200" dirty="0"/>
-          </a:p>
-        </p:txBody>
-      </p:sp>
-      <p:sp>
-        <p:nvSpPr>
-          <p:cNvPr id="20" name="Text 18"/>
-          <p:cNvSpPr txBox="1"/>
-          <p:nvPr/>
-        </p:nvSpPr>
-        <p:spPr>
-          <a:xfrm>
-            <a:off x="9631375" y="4069080"/>
-            <a:ext cx="2103120" cy="1005840"/>
-          </a:xfrm>
-          <a:prstGeom prst="rect">
-            <a:avLst/>
-          </a:prstGeom>
-          <a:noFill/>
-          <a:ln/>
-        </p:spPr>
-        <p:txBody>
-          <a:bodyPr wrap="square" lIns="0" tIns="0" rIns="0" bIns="0" rtlCol="0" anchor="t"/>
-          <a:lstStyle/>
-          <a:p>
-            <a:pPr algn="ctr" indent="0" marL="0">
-              <a:buNone/>
-            </a:pPr>
-            <a:r>
-              <a:rPr lang="en-US" sz="1200" dirty="0">
-                <a:solidFill>
-                  <a:srgbClr val="EEE0CB"/>
-                </a:solidFill>
-                <a:latin typeface="Poppins" pitchFamily="34" charset="0"/>
-                <a:ea typeface="Poppins" pitchFamily="34" charset="-122"/>
-                <a:cs typeface="Poppins" pitchFamily="34" charset="-120"/>
-              </a:rPr>
-              <a:t>Alcance y Mercado de Soluciones</a:t>
-            </a:r>
-            <a:endParaRPr lang="en-US" sz="1200" dirty="0"/>
-          </a:p>
-        </p:txBody>
-      </p:sp>
-      <p:sp>
-        <p:nvSpPr>
-          <p:cNvPr id="21" name="Shape 19"/>
+          <p:cNvPr id="29" name="Shape 27"/>
           <p:cNvSpPr/>
           <p:nvPr/>
         </p:nvSpPr>
@@ -4746,7 +5006,7 @@
       </p:sp>
       <p:sp>
         <p:nvSpPr>
-          <p:cNvPr id="22" name="Text 20"/>
+          <p:cNvPr id="30" name="Text 28"/>
           <p:cNvSpPr txBox="1"/>
           <p:nvPr/>
         </p:nvSpPr>

</xml_diff>